<commit_message>
Update on downsampling/filtering details
</commit_message>
<xml_diff>
--- a/fall_2025/Mathematical Model/Flight Controls Mathematical Model.pptx
+++ b/fall_2025/Mathematical Model/Flight Controls Mathematical Model.pptx
@@ -926,10 +926,25 @@
   <pc:docChgLst>
     <pc:chgData name="Brady Schick" userId="b2b33ab7-3f5f-4057-91d3-3d23bb8ba623" providerId="ADAL" clId="{119C1645-25BF-4125-9DBD-47C0423EEB24}"/>
     <pc:docChg chg="custSel addSld modSld">
-      <pc:chgData name="Brady Schick" userId="b2b33ab7-3f5f-4057-91d3-3d23bb8ba623" providerId="ADAL" clId="{119C1645-25BF-4125-9DBD-47C0423EEB24}" dt="2025-09-25T12:45:02.581" v="305" actId="20577"/>
+      <pc:chgData name="Brady Schick" userId="b2b33ab7-3f5f-4057-91d3-3d23bb8ba623" providerId="ADAL" clId="{119C1645-25BF-4125-9DBD-47C0423EEB24}" dt="2025-09-26T15:26:38.097" v="381" actId="20577"/>
       <pc:docMkLst>
         <pc:docMk/>
       </pc:docMkLst>
+      <pc:sldChg chg="modSp mod">
+        <pc:chgData name="Brady Schick" userId="b2b33ab7-3f5f-4057-91d3-3d23bb8ba623" providerId="ADAL" clId="{119C1645-25BF-4125-9DBD-47C0423EEB24}" dt="2025-09-26T15:26:38.097" v="381" actId="20577"/>
+        <pc:sldMkLst>
+          <pc:docMk/>
+          <pc:sldMk cId="9716602" sldId="263"/>
+        </pc:sldMkLst>
+        <pc:spChg chg="mod">
+          <ac:chgData name="Brady Schick" userId="b2b33ab7-3f5f-4057-91d3-3d23bb8ba623" providerId="ADAL" clId="{119C1645-25BF-4125-9DBD-47C0423EEB24}" dt="2025-09-26T15:26:38.097" v="381" actId="20577"/>
+          <ac:spMkLst>
+            <pc:docMk/>
+            <pc:sldMk cId="9716602" sldId="263"/>
+            <ac:spMk id="3" creationId="{6D5E60D6-9EBD-1A61-B20C-576B5403A52F}"/>
+          </ac:spMkLst>
+        </pc:spChg>
+      </pc:sldChg>
       <pc:sldChg chg="modSp add mod">
         <pc:chgData name="Brady Schick" userId="b2b33ab7-3f5f-4057-91d3-3d23bb8ba623" providerId="ADAL" clId="{119C1645-25BF-4125-9DBD-47C0423EEB24}" dt="2025-09-25T12:45:02.581" v="305" actId="20577"/>
         <pc:sldMkLst>
@@ -1349,7 +1364,7 @@
           <a:p>
             <a:fld id="{CCE55368-DE8C-481A-9FFC-45CFE5380273}" type="datetimeFigureOut">
               <a:rPr lang="en-US" smtClean="0"/>
-              <a:t>9/25/2025</a:t>
+              <a:t>9/26/2025</a:t>
             </a:fld>
             <a:endParaRPr lang="en-US"/>
           </a:p>
@@ -1547,7 +1562,7 @@
           <a:p>
             <a:fld id="{CCE55368-DE8C-481A-9FFC-45CFE5380273}" type="datetimeFigureOut">
               <a:rPr lang="en-US" smtClean="0"/>
-              <a:t>9/25/2025</a:t>
+              <a:t>9/26/2025</a:t>
             </a:fld>
             <a:endParaRPr lang="en-US"/>
           </a:p>
@@ -1755,7 +1770,7 @@
           <a:p>
             <a:fld id="{CCE55368-DE8C-481A-9FFC-45CFE5380273}" type="datetimeFigureOut">
               <a:rPr lang="en-US" smtClean="0"/>
-              <a:t>9/25/2025</a:t>
+              <a:t>9/26/2025</a:t>
             </a:fld>
             <a:endParaRPr lang="en-US"/>
           </a:p>
@@ -1953,7 +1968,7 @@
           <a:p>
             <a:fld id="{CCE55368-DE8C-481A-9FFC-45CFE5380273}" type="datetimeFigureOut">
               <a:rPr lang="en-US" smtClean="0"/>
-              <a:t>9/25/2025</a:t>
+              <a:t>9/26/2025</a:t>
             </a:fld>
             <a:endParaRPr lang="en-US"/>
           </a:p>
@@ -2228,7 +2243,7 @@
           <a:p>
             <a:fld id="{CCE55368-DE8C-481A-9FFC-45CFE5380273}" type="datetimeFigureOut">
               <a:rPr lang="en-US" smtClean="0"/>
-              <a:t>9/25/2025</a:t>
+              <a:t>9/26/2025</a:t>
             </a:fld>
             <a:endParaRPr lang="en-US"/>
           </a:p>
@@ -2493,7 +2508,7 @@
           <a:p>
             <a:fld id="{CCE55368-DE8C-481A-9FFC-45CFE5380273}" type="datetimeFigureOut">
               <a:rPr lang="en-US" smtClean="0"/>
-              <a:t>9/25/2025</a:t>
+              <a:t>9/26/2025</a:t>
             </a:fld>
             <a:endParaRPr lang="en-US"/>
           </a:p>
@@ -2905,7 +2920,7 @@
           <a:p>
             <a:fld id="{CCE55368-DE8C-481A-9FFC-45CFE5380273}" type="datetimeFigureOut">
               <a:rPr lang="en-US" smtClean="0"/>
-              <a:t>9/25/2025</a:t>
+              <a:t>9/26/2025</a:t>
             </a:fld>
             <a:endParaRPr lang="en-US"/>
           </a:p>
@@ -3046,7 +3061,7 @@
           <a:p>
             <a:fld id="{CCE55368-DE8C-481A-9FFC-45CFE5380273}" type="datetimeFigureOut">
               <a:rPr lang="en-US" smtClean="0"/>
-              <a:t>9/25/2025</a:t>
+              <a:t>9/26/2025</a:t>
             </a:fld>
             <a:endParaRPr lang="en-US"/>
           </a:p>
@@ -3159,7 +3174,7 @@
           <a:p>
             <a:fld id="{CCE55368-DE8C-481A-9FFC-45CFE5380273}" type="datetimeFigureOut">
               <a:rPr lang="en-US" smtClean="0"/>
-              <a:t>9/25/2025</a:t>
+              <a:t>9/26/2025</a:t>
             </a:fld>
             <a:endParaRPr lang="en-US"/>
           </a:p>
@@ -3470,7 +3485,7 @@
           <a:p>
             <a:fld id="{CCE55368-DE8C-481A-9FFC-45CFE5380273}" type="datetimeFigureOut">
               <a:rPr lang="en-US" smtClean="0"/>
-              <a:t>9/25/2025</a:t>
+              <a:t>9/26/2025</a:t>
             </a:fld>
             <a:endParaRPr lang="en-US"/>
           </a:p>
@@ -3758,7 +3773,7 @@
           <a:p>
             <a:fld id="{CCE55368-DE8C-481A-9FFC-45CFE5380273}" type="datetimeFigureOut">
               <a:rPr lang="en-US" smtClean="0"/>
-              <a:t>9/25/2025</a:t>
+              <a:t>9/26/2025</a:t>
             </a:fld>
             <a:endParaRPr lang="en-US"/>
           </a:p>
@@ -3999,7 +4014,7 @@
           <a:p>
             <a:fld id="{CCE55368-DE8C-481A-9FFC-45CFE5380273}" type="datetimeFigureOut">
               <a:rPr lang="en-US" smtClean="0"/>
-              <a:t>9/25/2025</a:t>
+              <a:t>9/26/2025</a:t>
             </a:fld>
             <a:endParaRPr lang="en-US"/>
           </a:p>
@@ -8645,7 +8660,7 @@
         <p:spPr/>
         <p:txBody>
           <a:bodyPr>
-            <a:normAutofit lnSpcReduction="10000"/>
+            <a:normAutofit fontScale="92500" lnSpcReduction="20000"/>
           </a:bodyPr>
           <a:lstStyle/>
           <a:p>
@@ -8653,6 +8668,25 @@
               <a:rPr lang="en-US" dirty="0"/>
               <a:t>2 Options to solve for slope (2 is probably best)</a:t>
             </a:r>
+          </a:p>
+          <a:p>
+            <a:r>
+              <a:rPr lang="en-US" dirty="0"/>
+              <a:t>ACTUALLY, 1 might be best if we </a:t>
+            </a:r>
+            <a:r>
+              <a:rPr lang="en-US" dirty="0" err="1"/>
+              <a:t>downsample</a:t>
+            </a:r>
+            <a:r>
+              <a:rPr lang="en-US" dirty="0"/>
+              <a:t> before getting </a:t>
+            </a:r>
+            <a:r>
+              <a:rPr lang="en-US"/>
+              <a:t>error values.</a:t>
+            </a:r>
+            <a:endParaRPr lang="en-US" dirty="0"/>
           </a:p>
           <a:p>
             <a:pPr marL="514350" indent="-514350">
@@ -8847,8 +8881,8 @@
           </a:p>
         </p:txBody>
       </p:sp>
-      <mc:AlternateContent xmlns:mc="http://schemas.openxmlformats.org/markup-compatibility/2006">
-        <mc:Choice xmlns:a14="http://schemas.microsoft.com/office/drawing/2010/main" Requires="a14">
+      <mc:AlternateContent xmlns:mc="http://schemas.openxmlformats.org/markup-compatibility/2006" xmlns:a14="http://schemas.microsoft.com/office/drawing/2010/main">
+        <mc:Choice Requires="a14">
           <p:sp>
             <p:nvSpPr>
               <p:cNvPr id="3" name="Content Placeholder 2">
@@ -9392,7 +9426,7 @@
             </p:txBody>
           </p:sp>
         </mc:Choice>
-        <mc:Fallback>
+        <mc:Fallback xmlns="">
           <p:sp>
             <p:nvSpPr>
               <p:cNvPr id="3" name="Content Placeholder 2">

</xml_diff>

<commit_message>
Started function to run PID controls
</commit_message>
<xml_diff>
--- a/fall_2025/Mathematical Model/Flight Controls Mathematical Model.pptx
+++ b/fall_2025/Mathematical Model/Flight Controls Mathematical Model.pptx
@@ -124,7 +124,7 @@
 <file path=ppt/revisionInfo.xml><?xml version="1.0" encoding="utf-8"?>
 <p1510:revInfo xmlns:a="http://schemas.openxmlformats.org/drawingml/2006/main" xmlns:r="http://schemas.openxmlformats.org/officeDocument/2006/relationships" xmlns:p1510="http://schemas.microsoft.com/office/powerpoint/2015/10/main">
   <p1510:revLst>
-    <p1510:client id="{119C1645-25BF-4125-9DBD-47C0423EEB24}" v="120" dt="2025-09-25T12:44:15.756"/>
+    <p1510:client id="{119C1645-25BF-4125-9DBD-47C0423EEB24}" v="121" dt="2025-10-02T22:40:07.270"/>
   </p1510:revLst>
 </p1510:revInfo>
 </file>
@@ -926,7 +926,7 @@
   <pc:docChgLst>
     <pc:chgData name="Brady Schick" userId="b2b33ab7-3f5f-4057-91d3-3d23bb8ba623" providerId="ADAL" clId="{119C1645-25BF-4125-9DBD-47C0423EEB24}"/>
     <pc:docChg chg="custSel addSld modSld">
-      <pc:chgData name="Brady Schick" userId="b2b33ab7-3f5f-4057-91d3-3d23bb8ba623" providerId="ADAL" clId="{119C1645-25BF-4125-9DBD-47C0423EEB24}" dt="2025-10-02T19:15:47.384" v="673"/>
+      <pc:chgData name="Brady Schick" userId="b2b33ab7-3f5f-4057-91d3-3d23bb8ba623" providerId="ADAL" clId="{119C1645-25BF-4125-9DBD-47C0423EEB24}" dt="2025-10-02T22:40:31.630" v="715" actId="1076"/>
       <pc:docMkLst>
         <pc:docMk/>
       </pc:docMkLst>
@@ -942,6 +942,37 @@
             <pc:docMk/>
             <pc:sldMk cId="4271143265" sldId="257"/>
             <ac:spMk id="3" creationId="{6D5E60D6-9EBD-1A61-B20C-576B5403A52F}"/>
+          </ac:spMkLst>
+        </pc:spChg>
+      </pc:sldChg>
+      <pc:sldChg chg="addSp modSp mod">
+        <pc:chgData name="Brady Schick" userId="b2b33ab7-3f5f-4057-91d3-3d23bb8ba623" providerId="ADAL" clId="{119C1645-25BF-4125-9DBD-47C0423EEB24}" dt="2025-10-02T22:40:31.630" v="715" actId="1076"/>
+        <pc:sldMkLst>
+          <pc:docMk/>
+          <pc:sldMk cId="1343786567" sldId="258"/>
+        </pc:sldMkLst>
+        <pc:spChg chg="add mod">
+          <ac:chgData name="Brady Schick" userId="b2b33ab7-3f5f-4057-91d3-3d23bb8ba623" providerId="ADAL" clId="{119C1645-25BF-4125-9DBD-47C0423EEB24}" dt="2025-10-02T22:40:31.630" v="715" actId="1076"/>
+          <ac:spMkLst>
+            <pc:docMk/>
+            <pc:sldMk cId="1343786567" sldId="258"/>
+            <ac:spMk id="2" creationId="{62FEA2C2-4AB9-7EDB-3F13-9FA6E36E9862}"/>
+          </ac:spMkLst>
+        </pc:spChg>
+        <pc:spChg chg="mod">
+          <ac:chgData name="Brady Schick" userId="b2b33ab7-3f5f-4057-91d3-3d23bb8ba623" providerId="ADAL" clId="{119C1645-25BF-4125-9DBD-47C0423EEB24}" dt="2025-10-02T22:39:53.217" v="676" actId="1076"/>
+          <ac:spMkLst>
+            <pc:docMk/>
+            <pc:sldMk cId="1343786567" sldId="258"/>
+            <ac:spMk id="154" creationId="{48BB7206-DB55-EF8C-E128-23F53EF41C5B}"/>
+          </ac:spMkLst>
+        </pc:spChg>
+        <pc:spChg chg="mod">
+          <ac:chgData name="Brady Schick" userId="b2b33ab7-3f5f-4057-91d3-3d23bb8ba623" providerId="ADAL" clId="{119C1645-25BF-4125-9DBD-47C0423EEB24}" dt="2025-10-02T22:39:57.424" v="677" actId="1076"/>
+          <ac:spMkLst>
+            <pc:docMk/>
+            <pc:sldMk cId="1343786567" sldId="258"/>
+            <ac:spMk id="155" creationId="{C39DF2C8-D6D2-FEB1-3A73-AEFC70AC5636}"/>
           </ac:spMkLst>
         </pc:spChg>
       </pc:sldChg>
@@ -8030,7 +8061,7 @@
         </p:nvSpPr>
         <p:spPr>
           <a:xfrm>
-            <a:off x="2594133" y="2592026"/>
+            <a:off x="5460015" y="2552348"/>
             <a:ext cx="866490" cy="230832"/>
           </a:xfrm>
           <a:prstGeom prst="rect">
@@ -8065,7 +8096,7 @@
         </p:nvSpPr>
         <p:spPr>
           <a:xfrm>
-            <a:off x="2636331" y="2961389"/>
+            <a:off x="5517929" y="2963062"/>
             <a:ext cx="633410" cy="369332"/>
           </a:xfrm>
           <a:prstGeom prst="rect">
@@ -8082,6 +8113,41 @@
             <a:r>
               <a:rPr lang="en-US" sz="900" dirty="0"/>
               <a:t>Desired Roll</a:t>
+            </a:r>
+          </a:p>
+        </p:txBody>
+      </p:sp>
+      <p:sp>
+        <p:nvSpPr>
+          <p:cNvPr id="2" name="TextBox 1">
+            <a:extLst>
+              <a:ext uri="{FF2B5EF4-FFF2-40B4-BE49-F238E27FC236}">
+                <a16:creationId xmlns:a16="http://schemas.microsoft.com/office/drawing/2014/main" id="{62FEA2C2-4AB9-7EDB-3F13-9FA6E36E9862}"/>
+              </a:ext>
+            </a:extLst>
+          </p:cNvPr>
+          <p:cNvSpPr txBox="1"/>
+          <p:nvPr/>
+        </p:nvSpPr>
+        <p:spPr>
+          <a:xfrm rot="16200000">
+            <a:off x="2851226" y="3985752"/>
+            <a:ext cx="1140542" cy="369332"/>
+          </a:xfrm>
+          <a:prstGeom prst="rect">
+            <a:avLst/>
+          </a:prstGeom>
+          <a:noFill/>
+        </p:spPr>
+        <p:txBody>
+          <a:bodyPr wrap="square" rtlCol="0">
+            <a:spAutoFit/>
+          </a:bodyPr>
+          <a:lstStyle/>
+          <a:p>
+            <a:r>
+              <a:rPr lang="en-US" sz="900" dirty="0"/>
+              <a:t>Estimated XY Position</a:t>
             </a:r>
           </a:p>
         </p:txBody>
@@ -8949,8 +9015,8 @@
           </a:p>
         </p:txBody>
       </p:sp>
-      <mc:AlternateContent xmlns:mc="http://schemas.openxmlformats.org/markup-compatibility/2006">
-        <mc:Choice xmlns:a14="http://schemas.microsoft.com/office/drawing/2010/main" Requires="a14">
+      <mc:AlternateContent xmlns:mc="http://schemas.openxmlformats.org/markup-compatibility/2006" xmlns:a14="http://schemas.microsoft.com/office/drawing/2010/main">
+        <mc:Choice Requires="a14">
           <p:sp>
             <p:nvSpPr>
               <p:cNvPr id="3" name="Content Placeholder 2">
@@ -9498,7 +9564,7 @@
             </p:txBody>
           </p:sp>
         </mc:Choice>
-        <mc:Fallback>
+        <mc:Fallback xmlns="">
           <p:sp>
             <p:nvSpPr>
               <p:cNvPr id="3" name="Content Placeholder 2">

</xml_diff>

<commit_message>
Update Flight Controls Mathematical Model.pptx
</commit_message>
<xml_diff>
--- a/fall_2025/Mathematical Model/Flight Controls Mathematical Model.pptx
+++ b/fall_2025/Mathematical Model/Flight Controls Mathematical Model.pptx
@@ -124,7 +124,7 @@
 <file path=ppt/revisionInfo.xml><?xml version="1.0" encoding="utf-8"?>
 <p1510:revInfo xmlns:a="http://schemas.openxmlformats.org/drawingml/2006/main" xmlns:r="http://schemas.openxmlformats.org/officeDocument/2006/relationships" xmlns:p1510="http://schemas.microsoft.com/office/powerpoint/2015/10/main">
   <p1510:revLst>
-    <p1510:client id="{119C1645-25BF-4125-9DBD-47C0423EEB24}" v="128" dt="2025-10-04T18:26:51.572"/>
+    <p1510:client id="{119C1645-25BF-4125-9DBD-47C0423EEB24}" v="129" dt="2025-11-21T14:23:35.062"/>
   </p1510:revLst>
 </p1510:revInfo>
 </file>
@@ -926,7 +926,7 @@
   <pc:docChgLst>
     <pc:chgData name="Brady Schick" userId="b2b33ab7-3f5f-4057-91d3-3d23bb8ba623" providerId="ADAL" clId="{119C1645-25BF-4125-9DBD-47C0423EEB24}"/>
     <pc:docChg chg="custSel addSld modSld">
-      <pc:chgData name="Brady Schick" userId="b2b33ab7-3f5f-4057-91d3-3d23bb8ba623" providerId="ADAL" clId="{119C1645-25BF-4125-9DBD-47C0423EEB24}" dt="2025-11-02T20:56:30.893" v="874" actId="20577"/>
+      <pc:chgData name="Brady Schick" userId="b2b33ab7-3f5f-4057-91d3-3d23bb8ba623" providerId="ADAL" clId="{119C1645-25BF-4125-9DBD-47C0423EEB24}" dt="2025-11-21T14:23:58.217" v="934" actId="6549"/>
       <pc:docMkLst>
         <pc:docMk/>
       </pc:docMkLst>
@@ -1461,22 +1461,22 @@
           </ac:spMkLst>
         </pc:spChg>
       </pc:sldChg>
-      <pc:sldChg chg="addSp modSp mod">
-        <pc:chgData name="Brady Schick" userId="b2b33ab7-3f5f-4057-91d3-3d23bb8ba623" providerId="ADAL" clId="{119C1645-25BF-4125-9DBD-47C0423EEB24}" dt="2025-11-02T20:56:30.893" v="874" actId="20577"/>
+      <pc:sldChg chg="addSp delSp modSp mod">
+        <pc:chgData name="Brady Schick" userId="b2b33ab7-3f5f-4057-91d3-3d23bb8ba623" providerId="ADAL" clId="{119C1645-25BF-4125-9DBD-47C0423EEB24}" dt="2025-11-21T14:23:58.217" v="934" actId="6549"/>
         <pc:sldMkLst>
           <pc:docMk/>
           <pc:sldMk cId="3786574737" sldId="267"/>
         </pc:sldMkLst>
         <pc:spChg chg="mod">
-          <ac:chgData name="Brady Schick" userId="b2b33ab7-3f5f-4057-91d3-3d23bb8ba623" providerId="ADAL" clId="{119C1645-25BF-4125-9DBD-47C0423EEB24}" dt="2025-11-02T20:56:30.893" v="874" actId="20577"/>
+          <ac:chgData name="Brady Schick" userId="b2b33ab7-3f5f-4057-91d3-3d23bb8ba623" providerId="ADAL" clId="{119C1645-25BF-4125-9DBD-47C0423EEB24}" dt="2025-11-21T14:23:58.217" v="934" actId="6549"/>
           <ac:spMkLst>
             <pc:docMk/>
             <pc:sldMk cId="3786574737" sldId="267"/>
             <ac:spMk id="3" creationId="{6D5E60D6-9EBD-1A61-B20C-576B5403A52F}"/>
           </ac:spMkLst>
         </pc:spChg>
-        <pc:picChg chg="add mod">
-          <ac:chgData name="Brady Schick" userId="b2b33ab7-3f5f-4057-91d3-3d23bb8ba623" providerId="ADAL" clId="{119C1645-25BF-4125-9DBD-47C0423EEB24}" dt="2025-10-04T18:26:51.572" v="821" actId="1076"/>
+        <pc:picChg chg="add del mod">
+          <ac:chgData name="Brady Schick" userId="b2b33ab7-3f5f-4057-91d3-3d23bb8ba623" providerId="ADAL" clId="{119C1645-25BF-4125-9DBD-47C0423EEB24}" dt="2025-11-21T14:23:35.062" v="902" actId="478"/>
           <ac:picMkLst>
             <pc:docMk/>
             <pc:sldMk cId="3786574737" sldId="267"/>
@@ -1903,7 +1903,7 @@
           <a:p>
             <a:fld id="{CCE55368-DE8C-481A-9FFC-45CFE5380273}" type="datetimeFigureOut">
               <a:rPr lang="en-US" smtClean="0"/>
-              <a:t>11/2/2025</a:t>
+              <a:t>11/21/2025</a:t>
             </a:fld>
             <a:endParaRPr lang="en-US"/>
           </a:p>
@@ -2101,7 +2101,7 @@
           <a:p>
             <a:fld id="{CCE55368-DE8C-481A-9FFC-45CFE5380273}" type="datetimeFigureOut">
               <a:rPr lang="en-US" smtClean="0"/>
-              <a:t>11/2/2025</a:t>
+              <a:t>11/21/2025</a:t>
             </a:fld>
             <a:endParaRPr lang="en-US"/>
           </a:p>
@@ -2309,7 +2309,7 @@
           <a:p>
             <a:fld id="{CCE55368-DE8C-481A-9FFC-45CFE5380273}" type="datetimeFigureOut">
               <a:rPr lang="en-US" smtClean="0"/>
-              <a:t>11/2/2025</a:t>
+              <a:t>11/21/2025</a:t>
             </a:fld>
             <a:endParaRPr lang="en-US"/>
           </a:p>
@@ -2507,7 +2507,7 @@
           <a:p>
             <a:fld id="{CCE55368-DE8C-481A-9FFC-45CFE5380273}" type="datetimeFigureOut">
               <a:rPr lang="en-US" smtClean="0"/>
-              <a:t>11/2/2025</a:t>
+              <a:t>11/21/2025</a:t>
             </a:fld>
             <a:endParaRPr lang="en-US"/>
           </a:p>
@@ -2782,7 +2782,7 @@
           <a:p>
             <a:fld id="{CCE55368-DE8C-481A-9FFC-45CFE5380273}" type="datetimeFigureOut">
               <a:rPr lang="en-US" smtClean="0"/>
-              <a:t>11/2/2025</a:t>
+              <a:t>11/21/2025</a:t>
             </a:fld>
             <a:endParaRPr lang="en-US"/>
           </a:p>
@@ -3047,7 +3047,7 @@
           <a:p>
             <a:fld id="{CCE55368-DE8C-481A-9FFC-45CFE5380273}" type="datetimeFigureOut">
               <a:rPr lang="en-US" smtClean="0"/>
-              <a:t>11/2/2025</a:t>
+              <a:t>11/21/2025</a:t>
             </a:fld>
             <a:endParaRPr lang="en-US"/>
           </a:p>
@@ -3459,7 +3459,7 @@
           <a:p>
             <a:fld id="{CCE55368-DE8C-481A-9FFC-45CFE5380273}" type="datetimeFigureOut">
               <a:rPr lang="en-US" smtClean="0"/>
-              <a:t>11/2/2025</a:t>
+              <a:t>11/21/2025</a:t>
             </a:fld>
             <a:endParaRPr lang="en-US"/>
           </a:p>
@@ -3600,7 +3600,7 @@
           <a:p>
             <a:fld id="{CCE55368-DE8C-481A-9FFC-45CFE5380273}" type="datetimeFigureOut">
               <a:rPr lang="en-US" smtClean="0"/>
-              <a:t>11/2/2025</a:t>
+              <a:t>11/21/2025</a:t>
             </a:fld>
             <a:endParaRPr lang="en-US"/>
           </a:p>
@@ -3713,7 +3713,7 @@
           <a:p>
             <a:fld id="{CCE55368-DE8C-481A-9FFC-45CFE5380273}" type="datetimeFigureOut">
               <a:rPr lang="en-US" smtClean="0"/>
-              <a:t>11/2/2025</a:t>
+              <a:t>11/21/2025</a:t>
             </a:fld>
             <a:endParaRPr lang="en-US"/>
           </a:p>
@@ -4024,7 +4024,7 @@
           <a:p>
             <a:fld id="{CCE55368-DE8C-481A-9FFC-45CFE5380273}" type="datetimeFigureOut">
               <a:rPr lang="en-US" smtClean="0"/>
-              <a:t>11/2/2025</a:t>
+              <a:t>11/21/2025</a:t>
             </a:fld>
             <a:endParaRPr lang="en-US"/>
           </a:p>
@@ -4312,7 +4312,7 @@
           <a:p>
             <a:fld id="{CCE55368-DE8C-481A-9FFC-45CFE5380273}" type="datetimeFigureOut">
               <a:rPr lang="en-US" smtClean="0"/>
-              <a:t>11/2/2025</a:t>
+              <a:t>11/21/2025</a:t>
             </a:fld>
             <a:endParaRPr lang="en-US"/>
           </a:p>
@@ -4553,7 +4553,7 @@
           <a:p>
             <a:fld id="{CCE55368-DE8C-481A-9FFC-45CFE5380273}" type="datetimeFigureOut">
               <a:rPr lang="en-US" smtClean="0"/>
-              <a:t>11/2/2025</a:t>
+              <a:t>11/21/2025</a:t>
             </a:fld>
             <a:endParaRPr lang="en-US"/>
           </a:p>
@@ -10325,7 +10325,7 @@
         </p:spPr>
         <p:txBody>
           <a:bodyPr>
-            <a:normAutofit lnSpcReduction="10000"/>
+            <a:normAutofit/>
           </a:bodyPr>
           <a:lstStyle/>
           <a:p>
@@ -10342,8 +10342,13 @@
             </a:r>
             <a:r>
               <a:rPr lang="en-US" dirty="0"/>
-              <a:t> = a*Thrust + b*Yaw + b*Pitch + b*Roll</a:t>
-            </a:r>
+              <a:t> = Thrust + Yaw - Pitch </a:t>
+            </a:r>
+            <a:r>
+              <a:rPr lang="en-US"/>
+              <a:t>+ Roll</a:t>
+            </a:r>
+            <a:endParaRPr lang="en-US" dirty="0"/>
           </a:p>
           <a:p>
             <a:pPr marL="0" indent="0" algn="ctr">
@@ -10359,7 +10364,7 @@
             </a:r>
             <a:r>
               <a:rPr lang="en-US" dirty="0"/>
-              <a:t> = a*Thrust - b*Yaw + b*Pitch - b*Roll</a:t>
+              <a:t> = Thrust - Yaw - Pitch - Roll</a:t>
             </a:r>
           </a:p>
           <a:p>
@@ -10376,7 +10381,7 @@
             </a:r>
             <a:r>
               <a:rPr lang="en-US" dirty="0"/>
-              <a:t> = a*Thrust - b*Yaw - b*Pitch + b*Roll</a:t>
+              <a:t> = Thrust - Yaw + Pitch + Roll</a:t>
             </a:r>
           </a:p>
           <a:p>
@@ -10393,7 +10398,7 @@
             </a:r>
             <a:r>
               <a:rPr lang="en-US" dirty="0"/>
-              <a:t> = a*Thrust + b*Yaw - b*Pitch - b*Roll</a:t>
+              <a:t> = Thrust + Yaw + Pitch - Roll</a:t>
             </a:r>
           </a:p>
           <a:p>
@@ -10401,41 +10406,6 @@
               <a:buNone/>
             </a:pPr>
             <a:endParaRPr lang="en-US" dirty="0"/>
-          </a:p>
-          <a:p>
-            <a:pPr marL="0" indent="0">
-              <a:buNone/>
-            </a:pPr>
-            <a:r>
-              <a:rPr lang="en-US" dirty="0"/>
-              <a:t>Note: a+3b = 1</a:t>
-            </a:r>
-          </a:p>
-          <a:p>
-            <a:pPr marL="0" indent="0">
-              <a:buNone/>
-            </a:pPr>
-            <a:r>
-              <a:rPr lang="en-US" dirty="0"/>
-              <a:t>This should keep the final values between 0 and 255 (crème </a:t>
-            </a:r>
-            <a:r>
-              <a:rPr lang="en-US" dirty="0" err="1"/>
-              <a:t>brûlée</a:t>
-            </a:r>
-            <a:r>
-              <a:rPr lang="en-US" dirty="0"/>
-              <a:t>)</a:t>
-            </a:r>
-          </a:p>
-          <a:p>
-            <a:pPr marL="0" indent="0">
-              <a:buNone/>
-            </a:pPr>
-            <a:r>
-              <a:rPr lang="en-US" dirty="0"/>
-              <a:t>NOTE: Yaw might need to be scaled differently than Pitch and Roll (might need a, b, and c.)</a:t>
-            </a:r>
           </a:p>
           <a:p>
             <a:pPr marL="0" indent="0" algn="ctr">
@@ -10500,53 +10470,6 @@
           </a:p>
         </p:txBody>
       </p:sp>
-      <p:pic>
-        <p:nvPicPr>
-          <p:cNvPr id="1026" name="Picture 2" descr="SpaghettiOs® Original Canned Pasta, 15 ...">
-            <a:extLst>
-              <a:ext uri="{FF2B5EF4-FFF2-40B4-BE49-F238E27FC236}">
-                <a16:creationId xmlns:a16="http://schemas.microsoft.com/office/drawing/2014/main" id="{8780EBFF-2D28-691F-5683-E378A005FFFD}"/>
-              </a:ext>
-            </a:extLst>
-          </p:cNvPr>
-          <p:cNvPicPr>
-            <a:picLocks noChangeAspect="1" noChangeArrowheads="1"/>
-          </p:cNvPicPr>
-          <p:nvPr/>
-        </p:nvPicPr>
-        <p:blipFill>
-          <a:blip r:embed="rId2">
-            <a:extLst>
-              <a:ext uri="{28A0092B-C50C-407E-A947-70E740481C1C}">
-                <a14:useLocalDpi xmlns:a14="http://schemas.microsoft.com/office/drawing/2010/main" val="0"/>
-              </a:ext>
-            </a:extLst>
-          </a:blip>
-          <a:srcRect/>
-          <a:stretch>
-            <a:fillRect/>
-          </a:stretch>
-        </p:blipFill>
-        <p:spPr bwMode="auto">
-          <a:xfrm>
-            <a:off x="838200" y="4784110"/>
-            <a:ext cx="553065" cy="553065"/>
-          </a:xfrm>
-          <a:prstGeom prst="rect">
-            <a:avLst/>
-          </a:prstGeom>
-          <a:noFill/>
-          <a:extLst>
-            <a:ext uri="{909E8E84-426E-40DD-AFC4-6F175D3DCCD1}">
-              <a14:hiddenFill xmlns:a14="http://schemas.microsoft.com/office/drawing/2010/main">
-                <a:solidFill>
-                  <a:srgbClr val="FFFFFF"/>
-                </a:solidFill>
-              </a14:hiddenFill>
-            </a:ext>
-          </a:extLst>
-        </p:spPr>
-      </p:pic>
     </p:spTree>
     <p:extLst>
       <p:ext uri="{BB962C8B-B14F-4D97-AF65-F5344CB8AC3E}">

</xml_diff>